<commit_message>
Update MACINTOSH_presentation.pptx and remove temporary file
</commit_message>
<xml_diff>
--- a/MACINTOSH_presentation.pptx
+++ b/MACINTOSH_presentation.pptx
@@ -4,6 +4,9 @@
   <p:sldMasterIdLst>
     <p:sldMasterId id="2147483648" r:id="rId1"/>
   </p:sldMasterIdLst>
+  <p:notesMasterIdLst>
+    <p:notesMasterId r:id="rId5"/>
+  </p:notesMasterIdLst>
   <p:sldIdLst>
     <p:sldId id="256" r:id="rId2"/>
     <p:sldId id="257" r:id="rId3"/>
@@ -126,7 +129,7 @@
 </file>
 
 <file path=ppt/notesMasters/notesMaster1.xml><?xml version="1.0" encoding="utf-8"?>
-<p:notesMaster xmlns:a="http://schemas.openxmlformats.org/drawingml/2006/main" xmlns:p="http://schemas.openxmlformats.org/presentationml/2006/main" xmlns:r="http://schemas.openxmlformats.org/officeDocument/2006/relationships">
+<p:notesMaster xmlns:a="http://schemas.openxmlformats.org/drawingml/2006/main" xmlns:r="http://schemas.openxmlformats.org/officeDocument/2006/relationships" xmlns:p="http://schemas.openxmlformats.org/presentationml/2006/main">
   <p:cSld>
     <p:bg>
       <p:bgRef idx="1001">
@@ -147,241 +150,16 @@
           <a:chExt cx="0" cy="0"/>
         </a:xfrm>
       </p:grpSpPr>
-      <p:sp>
-        <p:nvSpPr>
-          <p:cNvPr id="2" name="Header Placeholder 1"/>
-          <p:cNvSpPr>
-            <a:spLocks noGrp="1"/>
-          </p:cNvSpPr>
-          <p:nvPr>
-            <p:ph type="hdr" sz="quarter"/>
-          </p:nvPr>
-        </p:nvSpPr>
-        <p:spPr>
-          <a:xfrm>
-            <a:off x="0" y="0"/>
-            <a:ext cx="2971800" cy="457200"/>
-          </a:xfrm>
-          <a:prstGeom prst="rect">
-            <a:avLst/>
-          </a:prstGeom>
-        </p:spPr>
-        <p:txBody>
-          <a:bodyPr vert="horz" lIns="91440" tIns="45720" rIns="91440" bIns="45720" rtlCol="0"/>
-          <a:lstStyle>
-            <a:lvl1pPr algn="l">
-              <a:defRPr sz="1200"/>
-            </a:lvl1pPr>
-          </a:lstStyle>
-          <a:p>
-            <a:endParaRPr lang="en-US"/>
-          </a:p>
-        </p:txBody>
-      </p:sp>
-      <p:sp>
-        <p:nvSpPr>
-          <p:cNvPr id="3" name="Date Placeholder 2"/>
-          <p:cNvSpPr>
-            <a:spLocks noGrp="1"/>
-          </p:cNvSpPr>
-          <p:nvPr>
-            <p:ph type="dt" idx="1"/>
-          </p:nvPr>
-        </p:nvSpPr>
-        <p:spPr>
-          <a:xfrm>
-            <a:off x="3884613" y="0"/>
-            <a:ext cx="2971800" cy="457200"/>
-          </a:xfrm>
-          <a:prstGeom prst="rect">
-            <a:avLst/>
-          </a:prstGeom>
-        </p:spPr>
-        <p:txBody>
-          <a:bodyPr vert="horz" lIns="91440" tIns="45720" rIns="91440" bIns="45720" rtlCol="0"/>
-          <a:lstStyle>
-            <a:lvl1pPr algn="r">
-              <a:defRPr sz="1200"/>
-            </a:lvl1pPr>
-          </a:lstStyle>
-          <a:p>
-            <a:fld id="{0F89C1C7-3DCD-1040-A9CF-14679D8B5DDD}" type="datetimeFigureOut">
-              <a:rPr lang="en-US" smtClean="0"/>
-              <a:t>10/17/16</a:t>
-            </a:fld>
-            <a:endParaRPr lang="en-US"/>
-          </a:p>
-        </p:txBody>
-      </p:sp>
-      <p:sp>
-        <p:nvSpPr>
-          <p:cNvPr id="4" name="Slide Image Placeholder 3"/>
-          <p:cNvSpPr>
-            <a:spLocks noGrp="1" noRot="1" noChangeAspect="1"/>
-          </p:cNvSpPr>
-          <p:nvPr>
-            <p:ph type="sldImg" idx="2"/>
-          </p:nvPr>
-        </p:nvSpPr>
-        <p:spPr>
-          <a:xfrm>
-            <a:off x="1143000" y="685800"/>
-            <a:ext cx="4572000" cy="3429000"/>
-          </a:xfrm>
-          <a:prstGeom prst="rect">
-            <a:avLst/>
-          </a:prstGeom>
-          <a:noFill/>
-          <a:ln w="12700">
-            <a:solidFill>
-              <a:prstClr val="black"/>
-            </a:solidFill>
-          </a:ln>
-        </p:spPr>
-        <p:txBody>
-          <a:bodyPr vert="horz" lIns="91440" tIns="45720" rIns="91440" bIns="45720" rtlCol="0" anchor="ctr"/>
-          <a:lstStyle/>
-          <a:p>
-            <a:endParaRPr lang="en-US"/>
-          </a:p>
-        </p:txBody>
-      </p:sp>
-      <p:sp>
-        <p:nvSpPr>
-          <p:cNvPr id="5" name="Notes Placeholder 4"/>
-          <p:cNvSpPr>
-            <a:spLocks noGrp="1"/>
-          </p:cNvSpPr>
-          <p:nvPr>
-            <p:ph type="body" sz="quarter" idx="3"/>
-          </p:nvPr>
-        </p:nvSpPr>
-        <p:spPr>
-          <a:xfrm>
-            <a:off x="685800" y="4343400"/>
-            <a:ext cx="5486400" cy="4114800"/>
-          </a:xfrm>
-          <a:prstGeom prst="rect">
-            <a:avLst/>
-          </a:prstGeom>
-        </p:spPr>
-        <p:txBody>
-          <a:bodyPr vert="horz" lIns="91440" tIns="45720" rIns="91440" bIns="45720" rtlCol="0"/>
-          <a:lstStyle/>
-          <a:p>
-            <a:pPr lvl="0"/>
-            <a:r>
-              <a:rPr lang="en-US" smtClean="0"/>
-              <a:t>Click to edit Master text styles</a:t>
-            </a:r>
-          </a:p>
-          <a:p>
-            <a:pPr lvl="1"/>
-            <a:r>
-              <a:rPr lang="en-US" smtClean="0"/>
-              <a:t>Second level</a:t>
-            </a:r>
-          </a:p>
-          <a:p>
-            <a:pPr lvl="2"/>
-            <a:r>
-              <a:rPr lang="en-US" smtClean="0"/>
-              <a:t>Third level</a:t>
-            </a:r>
-          </a:p>
-          <a:p>
-            <a:pPr lvl="3"/>
-            <a:r>
-              <a:rPr lang="en-US" smtClean="0"/>
-              <a:t>Fourth level</a:t>
-            </a:r>
-          </a:p>
-          <a:p>
-            <a:pPr lvl="4"/>
-            <a:r>
-              <a:rPr lang="en-US" smtClean="0"/>
-              <a:t>Fifth level</a:t>
-            </a:r>
-            <a:endParaRPr lang="en-US"/>
-          </a:p>
-        </p:txBody>
-      </p:sp>
-      <p:sp>
-        <p:nvSpPr>
-          <p:cNvPr id="6" name="Footer Placeholder 5"/>
-          <p:cNvSpPr>
-            <a:spLocks noGrp="1"/>
-          </p:cNvSpPr>
-          <p:nvPr>
-            <p:ph type="ftr" sz="quarter" idx="4"/>
-          </p:nvPr>
-        </p:nvSpPr>
-        <p:spPr>
-          <a:xfrm>
-            <a:off x="0" y="8685213"/>
-            <a:ext cx="2971800" cy="457200"/>
-          </a:xfrm>
-          <a:prstGeom prst="rect">
-            <a:avLst/>
-          </a:prstGeom>
-        </p:spPr>
-        <p:txBody>
-          <a:bodyPr vert="horz" lIns="91440" tIns="45720" rIns="91440" bIns="45720" rtlCol="0" anchor="b"/>
-          <a:lstStyle>
-            <a:lvl1pPr algn="l">
-              <a:defRPr sz="1200"/>
-            </a:lvl1pPr>
-          </a:lstStyle>
-          <a:p>
-            <a:endParaRPr lang="en-US"/>
-          </a:p>
-        </p:txBody>
-      </p:sp>
-      <p:sp>
-        <p:nvSpPr>
-          <p:cNvPr id="7" name="Slide Number Placeholder 6"/>
-          <p:cNvSpPr>
-            <a:spLocks noGrp="1"/>
-          </p:cNvSpPr>
-          <p:nvPr>
-            <p:ph type="sldNum" sz="quarter" idx="5"/>
-          </p:nvPr>
-        </p:nvSpPr>
-        <p:spPr>
-          <a:xfrm>
-            <a:off x="3884613" y="8685213"/>
-            <a:ext cx="2971800" cy="457200"/>
-          </a:xfrm>
-          <a:prstGeom prst="rect">
-            <a:avLst/>
-          </a:prstGeom>
-        </p:spPr>
-        <p:txBody>
-          <a:bodyPr vert="horz" lIns="91440" tIns="45720" rIns="91440" bIns="45720" rtlCol="0" anchor="b"/>
-          <a:lstStyle>
-            <a:lvl1pPr algn="r">
-              <a:defRPr sz="1200"/>
-            </a:lvl1pPr>
-          </a:lstStyle>
-          <a:p>
-            <a:fld id="{BB5E49A5-4136-284D-997B-48E1D791AD67}" type="slidenum">
-              <a:rPr lang="en-US" smtClean="0"/>
-              <a:t>‹#›</a:t>
-            </a:fld>
-            <a:endParaRPr lang="en-US"/>
-          </a:p>
-        </p:txBody>
-      </p:sp>
     </p:spTree>
     <p:extLst>
       <p:ext uri="{BB962C8B-B14F-4D97-AF65-F5344CB8AC3E}">
-        <p14:creationId xmlns:p14="http://schemas.microsoft.com/office/powerpoint/2010/main" val="2623252185"/>
+        <p14:creationId xmlns:p14="http://schemas.microsoft.com/office/powerpoint/2010/main" val="2390287841"/>
       </p:ext>
     </p:extLst>
   </p:cSld>
   <p:clrMap bg1="lt1" tx1="dk1" bg2="lt2" tx2="dk2" accent1="accent1" accent2="accent2" accent3="accent3" accent4="accent4" accent5="accent5" accent6="accent6" hlink="hlink" folHlink="folHlink"/>
   <p:notesStyle>
-    <a:lvl1pPr marL="0" algn="l" defTabSz="457200" rtl="0" eaLnBrk="1" latinLnBrk="0" hangingPunct="1">
+    <a:lvl1pPr marL="0" algn="l" defTabSz="914400" rtl="0" eaLnBrk="1" latinLnBrk="0" hangingPunct="1">
       <a:defRPr sz="1200" kern="1200">
         <a:solidFill>
           <a:schemeClr val="tx1"/>
@@ -391,7 +169,7 @@
         <a:cs typeface="+mn-cs"/>
       </a:defRPr>
     </a:lvl1pPr>
-    <a:lvl2pPr marL="457200" algn="l" defTabSz="457200" rtl="0" eaLnBrk="1" latinLnBrk="0" hangingPunct="1">
+    <a:lvl2pPr marL="457200" algn="l" defTabSz="914400" rtl="0" eaLnBrk="1" latinLnBrk="0" hangingPunct="1">
       <a:defRPr sz="1200" kern="1200">
         <a:solidFill>
           <a:schemeClr val="tx1"/>
@@ -401,7 +179,7 @@
         <a:cs typeface="+mn-cs"/>
       </a:defRPr>
     </a:lvl2pPr>
-    <a:lvl3pPr marL="914400" algn="l" defTabSz="457200" rtl="0" eaLnBrk="1" latinLnBrk="0" hangingPunct="1">
+    <a:lvl3pPr marL="914400" algn="l" defTabSz="914400" rtl="0" eaLnBrk="1" latinLnBrk="0" hangingPunct="1">
       <a:defRPr sz="1200" kern="1200">
         <a:solidFill>
           <a:schemeClr val="tx1"/>
@@ -411,7 +189,7 @@
         <a:cs typeface="+mn-cs"/>
       </a:defRPr>
     </a:lvl3pPr>
-    <a:lvl4pPr marL="1371600" algn="l" defTabSz="457200" rtl="0" eaLnBrk="1" latinLnBrk="0" hangingPunct="1">
+    <a:lvl4pPr marL="1371600" algn="l" defTabSz="914400" rtl="0" eaLnBrk="1" latinLnBrk="0" hangingPunct="1">
       <a:defRPr sz="1200" kern="1200">
         <a:solidFill>
           <a:schemeClr val="tx1"/>
@@ -421,7 +199,7 @@
         <a:cs typeface="+mn-cs"/>
       </a:defRPr>
     </a:lvl4pPr>
-    <a:lvl5pPr marL="1828800" algn="l" defTabSz="457200" rtl="0" eaLnBrk="1" latinLnBrk="0" hangingPunct="1">
+    <a:lvl5pPr marL="1828800" algn="l" defTabSz="914400" rtl="0" eaLnBrk="1" latinLnBrk="0" hangingPunct="1">
       <a:defRPr sz="1200" kern="1200">
         <a:solidFill>
           <a:schemeClr val="tx1"/>
@@ -431,7 +209,7 @@
         <a:cs typeface="+mn-cs"/>
       </a:defRPr>
     </a:lvl5pPr>
-    <a:lvl6pPr marL="2286000" algn="l" defTabSz="457200" rtl="0" eaLnBrk="1" latinLnBrk="0" hangingPunct="1">
+    <a:lvl6pPr marL="2286000" algn="l" defTabSz="914400" rtl="0" eaLnBrk="1" latinLnBrk="0" hangingPunct="1">
       <a:defRPr sz="1200" kern="1200">
         <a:solidFill>
           <a:schemeClr val="tx1"/>
@@ -441,7 +219,7 @@
         <a:cs typeface="+mn-cs"/>
       </a:defRPr>
     </a:lvl6pPr>
-    <a:lvl7pPr marL="2743200" algn="l" defTabSz="457200" rtl="0" eaLnBrk="1" latinLnBrk="0" hangingPunct="1">
+    <a:lvl7pPr marL="2743200" algn="l" defTabSz="914400" rtl="0" eaLnBrk="1" latinLnBrk="0" hangingPunct="1">
       <a:defRPr sz="1200" kern="1200">
         <a:solidFill>
           <a:schemeClr val="tx1"/>
@@ -451,7 +229,7 @@
         <a:cs typeface="+mn-cs"/>
       </a:defRPr>
     </a:lvl7pPr>
-    <a:lvl8pPr marL="3200400" algn="l" defTabSz="457200" rtl="0" eaLnBrk="1" latinLnBrk="0" hangingPunct="1">
+    <a:lvl8pPr marL="3200400" algn="l" defTabSz="914400" rtl="0" eaLnBrk="1" latinLnBrk="0" hangingPunct="1">
       <a:defRPr sz="1200" kern="1200">
         <a:solidFill>
           <a:schemeClr val="tx1"/>
@@ -461,7 +239,7 @@
         <a:cs typeface="+mn-cs"/>
       </a:defRPr>
     </a:lvl8pPr>
-    <a:lvl9pPr marL="3657600" algn="l" defTabSz="457200" rtl="0" eaLnBrk="1" latinLnBrk="0" hangingPunct="1">
+    <a:lvl9pPr marL="3657600" algn="l" defTabSz="914400" rtl="0" eaLnBrk="1" latinLnBrk="0" hangingPunct="1">
       <a:defRPr sz="1200" kern="1200">
         <a:solidFill>
           <a:schemeClr val="tx1"/>
@@ -476,7 +254,7 @@
 </file>
 
 <file path=ppt/notesSlides/notesSlide1.xml><?xml version="1.0" encoding="utf-8"?>
-<p:notes xmlns:a="http://schemas.openxmlformats.org/drawingml/2006/main" xmlns:p="http://schemas.openxmlformats.org/presentationml/2006/main" xmlns:r="http://schemas.openxmlformats.org/officeDocument/2006/relationships">
+<p:notes xmlns:a="http://schemas.openxmlformats.org/drawingml/2006/main" xmlns:r="http://schemas.openxmlformats.org/officeDocument/2006/relationships" xmlns:p="http://schemas.openxmlformats.org/presentationml/2006/main">
   <p:cSld>
     <p:spTree>
       <p:nvGrpSpPr>
@@ -496,7 +274,7 @@
         <p:nvSpPr>
           <p:cNvPr id="2" name="Slide Image Placeholder 1"/>
           <p:cNvSpPr>
-            <a:spLocks noGrp="1"/>
+            <a:spLocks noGrp="1" noRot="1" noChangeAspect="1"/>
           </p:cNvSpPr>
           <p:nvPr>
             <p:ph type="sldImg" idx="2"/>
@@ -511,7 +289,7 @@
             <a:spLocks noGrp="1"/>
           </p:cNvSpPr>
           <p:nvPr>
-            <p:ph type="body" idx="3" sz="quarter"/>
+            <p:ph type="body" sz="quarter" idx="3"/>
           </p:nvPr>
         </p:nvSpPr>
         <p:spPr/>
@@ -528,7 +306,9 @@
               <a:t>We're team MACINTOSH - Mohammed, Jatin, and Nisarg. Our answering model is Qwen2.5-7B-Instruct, about 7.6 billion parameters, comfortably under the 8B cap, running locally through Ollama on a MacBook.</a:t>
             </a:r>
           </a:p>
-          <a:p/>
+          <a:p>
+            <a:endParaRPr/>
+          </a:p>
           <a:p>
             <a:r>
               <a:t>CAP CLARIFICATION:</a:t>
@@ -539,7 +319,9 @@
               <a:t>We also use a small cross-encoder reranker - bge-reranker-v2-m3, 278M params - but that only scores passages, it never produces an answer, so it does not count toward the 8B limit.</a:t>
             </a:r>
           </a:p>
-          <a:p/>
+          <a:p>
+            <a:endParaRPr/>
+          </a:p>
           <a:p>
             <a:r>
               <a:t>THE KEY INSIGHT (say this slowly - it frames everything):</a:t>
@@ -550,7 +332,9 @@
               <a:t>These 100 questions are long-tail Wikipedia facts - the height of an obscure tower, the range of a particular turtle. A 7B model simply doesn't have those memorised. So we treated this as a RETRIEVAL and READING-COMPREHENSION problem, not a reasoning one. The whole game is: find the right Wikipedia article, locate the exact sentence, and check every option against it.</a:t>
             </a:r>
           </a:p>
-          <a:p/>
+          <a:p>
+            <a:endParaRPr/>
+          </a:p>
           <a:p>
             <a:r>
               <a:t>SEARCH:</a:t>
@@ -561,7 +345,9 @@
               <a:t>And yes - we use internet search: full English Wikipedia articles through the MediaWiki API, with DuckDuckGo as a fallback when a title lookup misses.</a:t>
             </a:r>
           </a:p>
-          <a:p/>
+          <a:p>
+            <a:endParaRPr/>
+          </a:p>
           <a:p>
             <a:r>
               <a:t>(~40 seconds)</a:t>
@@ -576,7 +362,7 @@
             <a:spLocks noGrp="1"/>
           </p:cNvSpPr>
           <p:nvPr>
-            <p:ph type="sldNum" idx="5" sz="quarter"/>
+            <p:ph type="sldNum" sz="quarter" idx="5"/>
           </p:nvPr>
         </p:nvSpPr>
         <p:spPr/>
@@ -590,7 +376,7 @@
 </file>
 
 <file path=ppt/notesSlides/notesSlide2.xml><?xml version="1.0" encoding="utf-8"?>
-<p:notes xmlns:a="http://schemas.openxmlformats.org/drawingml/2006/main" xmlns:p="http://schemas.openxmlformats.org/presentationml/2006/main" xmlns:r="http://schemas.openxmlformats.org/officeDocument/2006/relationships">
+<p:notes xmlns:a="http://schemas.openxmlformats.org/drawingml/2006/main" xmlns:r="http://schemas.openxmlformats.org/officeDocument/2006/relationships" xmlns:p="http://schemas.openxmlformats.org/presentationml/2006/main">
   <p:cSld>
     <p:spTree>
       <p:nvGrpSpPr>
@@ -610,7 +396,7 @@
         <p:nvSpPr>
           <p:cNvPr id="2" name="Slide Image Placeholder 1"/>
           <p:cNvSpPr>
-            <a:spLocks noGrp="1"/>
+            <a:spLocks noGrp="1" noRot="1" noChangeAspect="1"/>
           </p:cNvSpPr>
           <p:nvPr>
             <p:ph type="sldImg" idx="2"/>
@@ -625,7 +411,7 @@
             <a:spLocks noGrp="1"/>
           </p:cNvSpPr>
           <p:nvPr>
-            <p:ph type="body" idx="3" sz="quarter"/>
+            <p:ph type="body" sz="quarter" idx="3"/>
           </p:nvPr>
         </p:nvSpPr>
         <p:spPr/>
@@ -642,7 +428,9 @@
               <a:t>For each question we extract the subject entity, retrieve full Wikipedia articles - not just snippets, because the answer is often a specific number buried in the body - chunk each article into ~130-word passages, and rerank with the cross-encoder, keeping the top five.</a:t>
             </a:r>
           </a:p>
-          <a:p/>
+          <a:p>
+            <a:endParaRPr/>
+          </a:p>
           <a:p>
             <a:r>
               <a:t>TWO PIECES WORTH HIGHLIGHTING:</a:t>
@@ -653,13 +441,17 @@
               <a:t>First, a DISAMBIGUATION RETRY: if the top passages don't actually contain the question's key nouns, we re-query using tokens from the answer options and re-rank. That's what stops us retrieving the monarch BUTTERFLY when the question is about the monarch BIRD family.</a:t>
             </a:r>
           </a:p>
-          <a:p/>
+          <a:p>
+            <a:endParaRPr/>
+          </a:p>
           <a:p>
             <a:r>
               <a:t>Second, the answer step is not a single guess. We run SELF-CONSISTENCY - five samples at temperature 0.7 - and we SHUFFLE the option order each time to cancel the bias small models have toward option A. Then for 'which statement accurately describes' questions we run a per-option CONTRADICTION CHECK: each option is labelled contradicted, supported, or unstated against the evidence, and that leads the decision.</a:t>
             </a:r>
           </a:p>
-          <a:p/>
+          <a:p>
+            <a:endParaRPr/>
+          </a:p>
           <a:p>
             <a:r>
               <a:t>CLOSE:</a:t>
@@ -670,7 +462,9 @@
               <a:t>Everything is logged to JSONL for reproducibility, and we never output 'Unknown' - we always commit a best guess, since we assumed no penalty for wrong answers.</a:t>
             </a:r>
           </a:p>
-          <a:p/>
+          <a:p>
+            <a:endParaRPr/>
+          </a:p>
           <a:p>
             <a:r>
               <a:t>(~50 seconds)</a:t>
@@ -685,7 +479,7 @@
             <a:spLocks noGrp="1"/>
           </p:cNvSpPr>
           <p:nvPr>
-            <p:ph type="sldNum" idx="5" sz="quarter"/>
+            <p:ph type="sldNum" sz="quarter" idx="5"/>
           </p:nvPr>
         </p:nvSpPr>
         <p:spPr/>
@@ -699,7 +493,7 @@
 </file>
 
 <file path=ppt/notesSlides/notesSlide3.xml><?xml version="1.0" encoding="utf-8"?>
-<p:notes xmlns:a="http://schemas.openxmlformats.org/drawingml/2006/main" xmlns:p="http://schemas.openxmlformats.org/presentationml/2006/main" xmlns:r="http://schemas.openxmlformats.org/officeDocument/2006/relationships">
+<p:notes xmlns:a="http://schemas.openxmlformats.org/drawingml/2006/main" xmlns:r="http://schemas.openxmlformats.org/officeDocument/2006/relationships" xmlns:p="http://schemas.openxmlformats.org/presentationml/2006/main">
   <p:cSld>
     <p:spTree>
       <p:nvGrpSpPr>
@@ -719,7 +513,7 @@
         <p:nvSpPr>
           <p:cNvPr id="2" name="Slide Image Placeholder 1"/>
           <p:cNvSpPr>
-            <a:spLocks noGrp="1"/>
+            <a:spLocks noGrp="1" noRot="1" noChangeAspect="1"/>
           </p:cNvSpPr>
           <p:nvPr>
             <p:ph type="sldImg" idx="2"/>
@@ -734,7 +528,7 @@
             <a:spLocks noGrp="1"/>
           </p:cNvSpPr>
           <p:nvPr>
-            <p:ph type="body" idx="3" sz="quarter"/>
+            <p:ph type="body" sz="quarter" idx="3"/>
           </p:nvPr>
         </p:nvSpPr>
         <p:spPr/>
@@ -751,7 +545,9 @@
               <a:t>100 out of 100 answered, no blanks, all valid A-E - and all produced by our declared 7.6B pipeline.</a:t>
             </a:r>
           </a:p>
-          <a:p/>
+          <a:p>
+            <a:endParaRPr/>
+          </a:p>
           <a:p>
             <a:r>
               <a:t>BIGGEST WIN:</a:t>
@@ -762,7 +558,9 @@
               <a:t>The single most useful upgrade was the disambiguation retry plus contradiction scoring. Together they fixed two whole classes of error: wrong-sense retrieval - Monarchidae vs the butterfly, Armet the helmet vs an armoured-vehicle company - and the minimal-edit distractor traps where options differ by one fact: factory-built vs privately built, 'black' vs dark purple, lipid vs carbohydrate.</a:t>
             </a:r>
           </a:p>
-          <a:p/>
+          <a:p>
+            <a:endParaRPr/>
+          </a:p>
           <a:p>
             <a:r>
               <a:t>BE HONEST ABOUT LIMITATIONS:</a:t>
@@ -773,7 +571,9 @@
               <a:t>Our coverage heuristic can still miss a sense collision when two topics share most of their vocabulary; numbers buried deep in article sections stay hard; and our 'confidence' is just self-consistency vote agreement, not calibrated accuracy - we saw at least one confidently-wrong answer. Wikipedia rate-limiting we handled with backoff and a cache.</a:t>
             </a:r>
           </a:p>
-          <a:p/>
+          <a:p>
+            <a:endParaRPr/>
+          </a:p>
           <a:p>
             <a:r>
               <a:t>TRANSPARENCY NOTE (provenance):</a:t>
@@ -784,7 +584,9 @@
               <a:t>Where the pipeline's own retrieved evidence directly contradicted its pick, we corrected those eight answers to match the evidence - for example, the question whose passage literally said 'individual foil and team sabre.' Those corrections are still grounded in what the 7B pipeline retrieved, so the provenance stays accurate.</a:t>
             </a:r>
           </a:p>
-          <a:p/>
+          <a:p>
+            <a:endParaRPr/>
+          </a:p>
           <a:p>
             <a:r>
               <a:t>CLOSE:</a:t>
@@ -795,7 +597,9 @@
               <a:t>Final score is pending grading; all code and the evidence log are on GitHub.</a:t>
             </a:r>
           </a:p>
-          <a:p/>
+          <a:p>
+            <a:endParaRPr/>
+          </a:p>
           <a:p>
             <a:r>
               <a:t>(~55 seconds)</a:t>
@@ -810,7 +614,7 @@
             <a:spLocks noGrp="1"/>
           </p:cNvSpPr>
           <p:nvPr>
-            <p:ph type="sldNum" idx="5" sz="quarter"/>
+            <p:ph type="sldNum" sz="quarter" idx="5"/>
           </p:nvPr>
         </p:nvSpPr>
         <p:spPr/>
@@ -6547,7 +6351,7 @@
         <p:spPr>
           <a:xfrm>
             <a:off x="822960" y="5230368"/>
-            <a:ext cx="5020056" cy="877824"/>
+            <a:ext cx="5020056" cy="803233"/>
           </a:xfrm>
           <a:prstGeom prst="rect">
             <a:avLst/>
@@ -6588,23 +6392,66 @@
               </a:spcBef>
             </a:pPr>
             <a:r>
-              <a:rPr sz="1600" b="1" i="0" dirty="0">
+              <a:rPr lang="en-US" sz="1600" b="1" i="0">
                 <a:solidFill>
                   <a:srgbClr val="35C2A7"/>
                 </a:solidFill>
                 <a:latin typeface="Calibri"/>
               </a:rPr>
-              <a:t>Pending  </a:t>
-            </a:r>
-            <a:r>
-              <a:rPr sz="1350" b="0" i="1" dirty="0">
+              <a:t>100/100= 100%</a:t>
+            </a:r>
+            <a:r>
+              <a:rPr lang="en-US" sz="1350" i="1">
                 <a:solidFill>
                   <a:srgbClr val="9FB3C4"/>
                 </a:solidFill>
                 <a:latin typeface="Calibri"/>
               </a:rPr>
-              <a:t>— update after grading.</a:t>
-            </a:r>
+              <a:t> </a:t>
+            </a:r>
+            <a:r>
+              <a:rPr lang="en-US" sz="1350" b="0" i="1" dirty="0">
+                <a:solidFill>
+                  <a:srgbClr val="9FB3C4"/>
+                </a:solidFill>
+                <a:latin typeface="Calibri"/>
+              </a:rPr>
+              <a:t>with any blank.</a:t>
+            </a:r>
+          </a:p>
+          <a:p>
+            <a:pPr>
+              <a:lnSpc>
+                <a:spcPct val="106000"/>
+              </a:lnSpc>
+              <a:spcBef>
+                <a:spcPts val="200"/>
+              </a:spcBef>
+            </a:pPr>
+            <a:r>
+              <a:rPr lang="en-US" sz="1350" i="1" dirty="0">
+                <a:solidFill>
+                  <a:srgbClr val="9FB3C4"/>
+                </a:solidFill>
+                <a:latin typeface="Calibri"/>
+              </a:rPr>
+              <a:t>And correct </a:t>
+            </a:r>
+            <a:r>
+              <a:rPr lang="en-US" sz="1600" b="1" dirty="0">
+                <a:solidFill>
+                  <a:srgbClr val="35C2A7"/>
+                </a:solidFill>
+                <a:latin typeface="Calibri"/>
+              </a:rPr>
+              <a:t>79/100= 79%</a:t>
+            </a:r>
+            <a:endParaRPr sz="1600" b="1" dirty="0">
+              <a:solidFill>
+                <a:srgbClr val="35C2A7"/>
+              </a:solidFill>
+              <a:latin typeface="Calibri"/>
+            </a:endParaRPr>
           </a:p>
         </p:txBody>
       </p:sp>
@@ -7090,44 +6937,44 @@
         <a:sysClr val="window" lastClr="FFFFFF"/>
       </a:lt1>
       <a:dk2>
-        <a:srgbClr val="1F497D"/>
+        <a:srgbClr val="0E2841"/>
       </a:dk2>
       <a:lt2>
-        <a:srgbClr val="EEECE1"/>
+        <a:srgbClr val="E8E8E8"/>
       </a:lt2>
       <a:accent1>
-        <a:srgbClr val="4F81BD"/>
+        <a:srgbClr val="156082"/>
       </a:accent1>
       <a:accent2>
-        <a:srgbClr val="C0504D"/>
+        <a:srgbClr val="E97132"/>
       </a:accent2>
       <a:accent3>
-        <a:srgbClr val="9BBB59"/>
+        <a:srgbClr val="196B24"/>
       </a:accent3>
       <a:accent4>
-        <a:srgbClr val="8064A2"/>
+        <a:srgbClr val="0F9ED5"/>
       </a:accent4>
       <a:accent5>
-        <a:srgbClr val="4BACC6"/>
+        <a:srgbClr val="A02B93"/>
       </a:accent5>
       <a:accent6>
-        <a:srgbClr val="F79646"/>
+        <a:srgbClr val="4EA72E"/>
       </a:accent6>
       <a:hlink>
-        <a:srgbClr val="0000FF"/>
+        <a:srgbClr val="467886"/>
       </a:hlink>
       <a:folHlink>
-        <a:srgbClr val="800080"/>
+        <a:srgbClr val="96607D"/>
       </a:folHlink>
     </a:clrScheme>
     <a:fontScheme name="Office">
       <a:majorFont>
-        <a:latin typeface="Calibri"/>
+        <a:latin typeface="Aptos Display" panose="02110004020202020204"/>
         <a:ea typeface=""/>
         <a:cs typeface=""/>
-        <a:font script="Jpan" typeface="ＭＳ Ｐゴシック"/>
+        <a:font script="Jpan" typeface="游ゴシック Light"/>
         <a:font script="Hang" typeface="맑은 고딕"/>
-        <a:font script="Hans" typeface="宋体"/>
+        <a:font script="Hans" typeface="等线 Light"/>
         <a:font script="Hant" typeface="新細明體"/>
         <a:font script="Arab" typeface="Times New Roman"/>
         <a:font script="Hebr" typeface="Times New Roman"/>
@@ -7155,14 +7002,31 @@
         <a:font script="Viet" typeface="Times New Roman"/>
         <a:font script="Uigh" typeface="Microsoft Uighur"/>
         <a:font script="Geor" typeface="Sylfaen"/>
+        <a:font script="Armn" typeface="Arial"/>
+        <a:font script="Bugi" typeface="Leelawadee UI"/>
+        <a:font script="Bopo" typeface="Microsoft JhengHei"/>
+        <a:font script="Java" typeface="Javanese Text"/>
+        <a:font script="Lisu" typeface="Segoe UI"/>
+        <a:font script="Mymr" typeface="Myanmar Text"/>
+        <a:font script="Nkoo" typeface="Ebrima"/>
+        <a:font script="Olck" typeface="Nirmala UI"/>
+        <a:font script="Osma" typeface="Ebrima"/>
+        <a:font script="Phag" typeface="Phagspa"/>
+        <a:font script="Syrn" typeface="Estrangelo Edessa"/>
+        <a:font script="Syrj" typeface="Estrangelo Edessa"/>
+        <a:font script="Syre" typeface="Estrangelo Edessa"/>
+        <a:font script="Sora" typeface="Nirmala UI"/>
+        <a:font script="Tale" typeface="Microsoft Tai Le"/>
+        <a:font script="Talu" typeface="Microsoft New Tai Lue"/>
+        <a:font script="Tfng" typeface="Ebrima"/>
       </a:majorFont>
       <a:minorFont>
-        <a:latin typeface="Calibri"/>
+        <a:latin typeface="Aptos" panose="02110004020202020204"/>
         <a:ea typeface=""/>
         <a:cs typeface=""/>
-        <a:font script="Jpan" typeface="ＭＳ Ｐゴシック"/>
+        <a:font script="Jpan" typeface="游ゴシック"/>
         <a:font script="Hang" typeface="맑은 고딕"/>
-        <a:font script="Hans" typeface="宋体"/>
+        <a:font script="Hans" typeface="等线"/>
         <a:font script="Hant" typeface="新細明體"/>
         <a:font script="Arab" typeface="Arial"/>
         <a:font script="Hebr" typeface="Arial"/>
@@ -7190,6 +7054,23 @@
         <a:font script="Viet" typeface="Arial"/>
         <a:font script="Uigh" typeface="Microsoft Uighur"/>
         <a:font script="Geor" typeface="Sylfaen"/>
+        <a:font script="Armn" typeface="Arial"/>
+        <a:font script="Bugi" typeface="Leelawadee UI"/>
+        <a:font script="Bopo" typeface="Microsoft JhengHei"/>
+        <a:font script="Java" typeface="Javanese Text"/>
+        <a:font script="Lisu" typeface="Segoe UI"/>
+        <a:font script="Mymr" typeface="Myanmar Text"/>
+        <a:font script="Nkoo" typeface="Ebrima"/>
+        <a:font script="Olck" typeface="Nirmala UI"/>
+        <a:font script="Osma" typeface="Ebrima"/>
+        <a:font script="Phag" typeface="Phagspa"/>
+        <a:font script="Syrn" typeface="Estrangelo Edessa"/>
+        <a:font script="Syrj" typeface="Estrangelo Edessa"/>
+        <a:font script="Syre" typeface="Estrangelo Edessa"/>
+        <a:font script="Sora" typeface="Nirmala UI"/>
+        <a:font script="Tale" typeface="Microsoft Tai Le"/>
+        <a:font script="Talu" typeface="Microsoft New Tai Lue"/>
+        <a:font script="Tfng" typeface="Ebrima"/>
       </a:minorFont>
     </a:fontScheme>
     <a:fmtScheme name="Office">
@@ -7201,180 +7082,136 @@
           <a:gsLst>
             <a:gs pos="0">
               <a:schemeClr val="phClr">
-                <a:tint val="50000"/>
-                <a:satMod val="300000"/>
+                <a:lumMod val="110000"/>
+                <a:satMod val="105000"/>
+                <a:tint val="67000"/>
               </a:schemeClr>
             </a:gs>
-            <a:gs pos="35000">
+            <a:gs pos="50000">
               <a:schemeClr val="phClr">
-                <a:tint val="37000"/>
-                <a:satMod val="300000"/>
+                <a:lumMod val="105000"/>
+                <a:satMod val="103000"/>
+                <a:tint val="73000"/>
               </a:schemeClr>
             </a:gs>
             <a:gs pos="100000">
               <a:schemeClr val="phClr">
-                <a:tint val="15000"/>
-                <a:satMod val="350000"/>
+                <a:lumMod val="105000"/>
+                <a:satMod val="109000"/>
+                <a:tint val="81000"/>
               </a:schemeClr>
             </a:gs>
           </a:gsLst>
-          <a:lin ang="16200000" scaled="1"/>
+          <a:lin ang="5400000" scaled="0"/>
         </a:gradFill>
         <a:gradFill rotWithShape="1">
           <a:gsLst>
             <a:gs pos="0">
               <a:schemeClr val="phClr">
-                <a:tint val="100000"/>
+                <a:satMod val="103000"/>
+                <a:lumMod val="102000"/>
+                <a:tint val="94000"/>
+              </a:schemeClr>
+            </a:gs>
+            <a:gs pos="50000">
+              <a:schemeClr val="phClr">
+                <a:satMod val="110000"/>
+                <a:lumMod val="100000"/>
                 <a:shade val="100000"/>
-                <a:satMod val="130000"/>
               </a:schemeClr>
             </a:gs>
             <a:gs pos="100000">
               <a:schemeClr val="phClr">
-                <a:tint val="50000"/>
-                <a:shade val="100000"/>
-                <a:satMod val="350000"/>
+                <a:lumMod val="99000"/>
+                <a:satMod val="120000"/>
+                <a:shade val="78000"/>
               </a:schemeClr>
             </a:gs>
           </a:gsLst>
-          <a:lin ang="16200000" scaled="0"/>
+          <a:lin ang="5400000" scaled="0"/>
         </a:gradFill>
       </a:fillStyleLst>
       <a:lnStyleLst>
-        <a:ln w="9525" cap="flat" cmpd="sng" algn="ctr">
+        <a:ln w="12700" cap="flat" cmpd="sng" algn="ctr">
           <a:solidFill>
-            <a:schemeClr val="phClr">
-              <a:shade val="95000"/>
-              <a:satMod val="105000"/>
-            </a:schemeClr>
+            <a:schemeClr val="phClr"/>
           </a:solidFill>
           <a:prstDash val="solid"/>
+          <a:miter lim="800000"/>
+        </a:ln>
+        <a:ln w="19050" cap="flat" cmpd="sng" algn="ctr">
+          <a:solidFill>
+            <a:schemeClr val="phClr"/>
+          </a:solidFill>
+          <a:prstDash val="solid"/>
+          <a:miter lim="800000"/>
         </a:ln>
         <a:ln w="25400" cap="flat" cmpd="sng" algn="ctr">
           <a:solidFill>
             <a:schemeClr val="phClr"/>
           </a:solidFill>
           <a:prstDash val="solid"/>
-        </a:ln>
-        <a:ln w="38100" cap="flat" cmpd="sng" algn="ctr">
-          <a:solidFill>
-            <a:schemeClr val="phClr"/>
-          </a:solidFill>
-          <a:prstDash val="solid"/>
+          <a:miter lim="800000"/>
         </a:ln>
       </a:lnStyleLst>
       <a:effectStyleLst>
         <a:effectStyle>
+          <a:effectLst/>
+        </a:effectStyle>
+        <a:effectStyle>
+          <a:effectLst/>
+        </a:effectStyle>
+        <a:effectStyle>
           <a:effectLst>
-            <a:outerShdw blurRad="40000" dist="20000" dir="5400000" rotWithShape="0">
+            <a:outerShdw blurRad="57150" dist="19050" dir="5400000" algn="ctr" rotWithShape="0">
               <a:srgbClr val="000000">
-                <a:alpha val="38000"/>
+                <a:alpha val="63000"/>
               </a:srgbClr>
             </a:outerShdw>
           </a:effectLst>
-        </a:effectStyle>
-        <a:effectStyle>
-          <a:effectLst>
-            <a:outerShdw blurRad="40000" dist="23000" dir="5400000" rotWithShape="0">
-              <a:srgbClr val="000000">
-                <a:alpha val="35000"/>
-              </a:srgbClr>
-            </a:outerShdw>
-          </a:effectLst>
-        </a:effectStyle>
-        <a:effectStyle>
-          <a:effectLst>
-            <a:outerShdw blurRad="40000" dist="23000" dir="5400000" rotWithShape="0">
-              <a:srgbClr val="000000">
-                <a:alpha val="35000"/>
-              </a:srgbClr>
-            </a:outerShdw>
-          </a:effectLst>
-          <a:scene3d>
-            <a:camera prst="orthographicFront">
-              <a:rot lat="0" lon="0" rev="0"/>
-            </a:camera>
-            <a:lightRig rig="threePt" dir="t">
-              <a:rot lat="0" lon="0" rev="1200000"/>
-            </a:lightRig>
-          </a:scene3d>
-          <a:sp3d>
-            <a:bevelT w="63500" h="25400"/>
-          </a:sp3d>
         </a:effectStyle>
       </a:effectStyleLst>
       <a:bgFillStyleLst>
         <a:solidFill>
           <a:schemeClr val="phClr"/>
         </a:solidFill>
+        <a:solidFill>
+          <a:schemeClr val="phClr">
+            <a:tint val="95000"/>
+            <a:satMod val="170000"/>
+          </a:schemeClr>
+        </a:solidFill>
         <a:gradFill rotWithShape="1">
           <a:gsLst>
             <a:gs pos="0">
               <a:schemeClr val="phClr">
-                <a:tint val="40000"/>
-                <a:satMod val="350000"/>
+                <a:tint val="93000"/>
+                <a:satMod val="150000"/>
+                <a:shade val="98000"/>
+                <a:lumMod val="102000"/>
               </a:schemeClr>
             </a:gs>
-            <a:gs pos="40000">
+            <a:gs pos="50000">
               <a:schemeClr val="phClr">
-                <a:tint val="45000"/>
-                <a:shade val="99000"/>
-                <a:satMod val="350000"/>
+                <a:tint val="98000"/>
+                <a:satMod val="130000"/>
+                <a:shade val="90000"/>
+                <a:lumMod val="103000"/>
               </a:schemeClr>
             </a:gs>
             <a:gs pos="100000">
               <a:schemeClr val="phClr">
-                <a:shade val="20000"/>
-                <a:satMod val="255000"/>
+                <a:shade val="63000"/>
+                <a:satMod val="120000"/>
               </a:schemeClr>
             </a:gs>
           </a:gsLst>
-          <a:path path="circle">
-            <a:fillToRect l="50000" t="-80000" r="50000" b="180000"/>
-          </a:path>
-        </a:gradFill>
-        <a:gradFill rotWithShape="1">
-          <a:gsLst>
-            <a:gs pos="0">
-              <a:schemeClr val="phClr">
-                <a:tint val="80000"/>
-                <a:satMod val="300000"/>
-              </a:schemeClr>
-            </a:gs>
-            <a:gs pos="100000">
-              <a:schemeClr val="phClr">
-                <a:shade val="30000"/>
-                <a:satMod val="200000"/>
-              </a:schemeClr>
-            </a:gs>
-          </a:gsLst>
-          <a:path path="circle">
-            <a:fillToRect l="50000" t="50000" r="50000" b="50000"/>
-          </a:path>
+          <a:lin ang="5400000" scaled="0"/>
         </a:gradFill>
       </a:bgFillStyleLst>
     </a:fmtScheme>
   </a:themeElements>
   <a:objectDefaults>
-    <a:spDef>
-      <a:spPr/>
-      <a:bodyPr/>
-      <a:lstStyle/>
-      <a:style>
-        <a:lnRef idx="1">
-          <a:schemeClr val="accent1"/>
-        </a:lnRef>
-        <a:fillRef idx="3">
-          <a:schemeClr val="accent1"/>
-        </a:fillRef>
-        <a:effectRef idx="2">
-          <a:schemeClr val="accent1"/>
-        </a:effectRef>
-        <a:fontRef idx="minor">
-          <a:schemeClr val="lt1"/>
-        </a:fontRef>
-      </a:style>
-    </a:spDef>
     <a:lnDef>
       <a:spPr/>
       <a:bodyPr/>
@@ -7396,5 +7233,10 @@
     </a:lnDef>
   </a:objectDefaults>
   <a:extraClrSchemeLst/>
+  <a:extLst>
+    <a:ext uri="{05A4C25C-085E-4340-85A3-A5531E510DB2}">
+      <thm15:themeFamily xmlns:thm15="http://schemas.microsoft.com/office/thememl/2012/main" name="Office Theme" id="{2E142A2C-CD16-42D6-873A-C26D2A0506FA}" vid="{1BDDFF52-6CD6-40A5-AB3C-68EB2F1E4D0A}"/>
+    </a:ext>
+  </a:extLst>
 </a:theme>
 </file>
</xml_diff>